<commit_message>
feat(pitch): animated web pitch deck (reuses deck-stage engine); docs(ui-guide): Dev 2 copies notiky-app directly
</commit_message>
<xml_diff>
--- a/docs/areeza-deck.pptx
+++ b/docs/areeza-deck.pptx
@@ -1907,7 +1907,7 @@
                 <a:ea typeface="Calibri" pitchFamily="34" charset="-122"/>
                 <a:cs typeface="Calibri" pitchFamily="34" charset="-120"/>
               </a:rPr>
-              <a:t>MILLIY AI XAKATON  ·  SUD TIZIMI TREKI  ·  ANDIJON 2026</a:t>
+              <a:t>NATIONAL AI HACKATHON  ·  COURT / JUSTICE TRACK  ·  ANDIJAN 2026</a:t>
             </a:r>
             <a:endParaRPr lang="en-US" sz="1250" dirty="0"/>
           </a:p>
@@ -1961,7 +1961,7 @@
         <p:spPr>
           <a:xfrm>
             <a:off x="868680" y="3401568"/>
-            <a:ext cx="10058400" cy="548640"/>
+            <a:ext cx="10515600" cy="548640"/>
           </a:xfrm>
           <a:prstGeom prst="rect">
             <a:avLst/>
@@ -1977,7 +1977,7 @@
               <a:buNone/>
             </a:pPr>
             <a:r>
-              <a:rPr lang="en-US" sz="2500" i="1" dirty="0">
+              <a:rPr lang="en-US" sz="2400" i="1" dirty="0">
                 <a:solidFill>
                   <a:srgbClr val="E0BE54"/>
                 </a:solidFill>
@@ -1985,9 +1985,9 @@
                 <a:ea typeface="Georgia" pitchFamily="34" charset="-122"/>
                 <a:cs typeface="Georgia" pitchFamily="34" charset="-120"/>
               </a:rPr>
-              <a:t>Sudga tayyor ariza — bir gapdan.</a:t>
-            </a:r>
-            <a:endParaRPr lang="en-US" sz="2500" dirty="0"/>
+              <a:t>A court-ready legal filing — from a single sentence.</a:t>
+            </a:r>
+            <a:endParaRPr lang="en-US" sz="2400" dirty="0"/>
           </a:p>
         </p:txBody>
       </p:sp>
@@ -2024,7 +2024,7 @@
                 <a:ea typeface="Calibri" pitchFamily="34" charset="-122"/>
                 <a:cs typeface="Calibri" pitchFamily="34" charset="-120"/>
               </a:rPr>
-              <a:t>Fuqaro va raqamli adliya o'rtasidagi intellektual qatlam.</a:t>
+              <a:t>The intelligence layer for digital justice in Uzbekistan.</a:t>
             </a:r>
             <a:endParaRPr lang="en-US" sz="1600" dirty="0"/>
           </a:p>
@@ -2063,7 +2063,7 @@
                 <a:ea typeface="Calibri" pitchFamily="34" charset="-122"/>
                 <a:cs typeface="Calibri" pitchFamily="34" charset="-120"/>
               </a:rPr>
-              <a:t>Oliy Sud maslahatchilari bilan</a:t>
+              <a:t>Built with advisors from Oliy Sud</a:t>
             </a:r>
             <a:pPr indent="0" marL="0">
               <a:buNone/>
@@ -2077,7 +2077,7 @@
                 <a:ea typeface="Calibri" pitchFamily="34" charset="-122"/>
                 <a:cs typeface="Calibri" pitchFamily="34" charset="-120"/>
               </a:rPr>
-              <a:t> qurilmoqda</a:t>
+              <a:t> — the Supreme Court of Uzbekistan</a:t>
             </a:r>
             <a:endParaRPr lang="en-US" sz="1400" dirty="0"/>
           </a:p>
@@ -2148,7 +2148,7 @@
                 <a:ea typeface="Calibri" pitchFamily="34" charset="-122"/>
                 <a:cs typeface="Calibri" pitchFamily="34" charset="-120"/>
               </a:rPr>
-              <a:t>YO'L XARITASI</a:t>
+              <a:t>ROADMAP</a:t>
             </a:r>
             <a:endParaRPr lang="en-US" sz="1250" dirty="0"/>
           </a:p>
@@ -2190,7 +2190,7 @@
                 <a:ea typeface="Georgia" pitchFamily="34" charset="-122"/>
                 <a:cs typeface="Georgia" pitchFamily="34" charset="-120"/>
               </a:rPr>
-              <a:t>G'alaba → davlat qabuli → mintaqa.</a:t>
+              <a:t>Win → government adoption → region.</a:t>
             </a:r>
             <a:endParaRPr lang="en-US" sz="3100" dirty="0"/>
           </a:p>
@@ -2277,7 +2277,7 @@
                 <a:ea typeface="Georgia" pitchFamily="34" charset="-122"/>
                 <a:cs typeface="Georgia" pitchFamily="34" charset="-120"/>
               </a:rPr>
-              <a:t>Hozir</a:t>
+              <a:t>Now</a:t>
             </a:r>
             <a:endParaRPr lang="en-US" sz="1600" dirty="0"/>
           </a:p>
@@ -2319,7 +2319,7 @@
                 <a:ea typeface="Calibri" pitchFamily="34" charset="-122"/>
                 <a:cs typeface="Calibri" pitchFamily="34" charset="-120"/>
               </a:rPr>
-              <a:t>Ishlaydigan MVP</a:t>
+              <a:t>Working MVP</a:t>
             </a:r>
             <a:endParaRPr lang="en-US" sz="1250" dirty="0"/>
           </a:p>
@@ -2383,7 +2383,7 @@
                 <a:ea typeface="Georgia" pitchFamily="34" charset="-122"/>
                 <a:cs typeface="Georgia" pitchFamily="34" charset="-120"/>
               </a:rPr>
-              <a:t>6-iyun</a:t>
+              <a:t>Jun 6</a:t>
             </a:r>
             <a:endParaRPr lang="en-US" sz="1900" dirty="0"/>
           </a:p>
@@ -2425,7 +2425,7 @@
                 <a:ea typeface="Calibri" pitchFamily="34" charset="-122"/>
                 <a:cs typeface="Calibri" pitchFamily="34" charset="-120"/>
               </a:rPr>
-              <a:t>G'alaba (Sud treki)</a:t>
+              <a:t>Win the track</a:t>
             </a:r>
             <a:endParaRPr lang="en-US" sz="1250" dirty="0"/>
           </a:p>
@@ -2489,7 +2489,7 @@
                 <a:ea typeface="Georgia" pitchFamily="34" charset="-122"/>
                 <a:cs typeface="Georgia" pitchFamily="34" charset="-120"/>
               </a:rPr>
-              <a:t>3 oy</a:t>
+              <a:t>3 mo</a:t>
             </a:r>
             <a:endParaRPr lang="en-US" sz="1600" dirty="0"/>
           </a:p>
@@ -2595,7 +2595,7 @@
                 <a:ea typeface="Georgia" pitchFamily="34" charset="-122"/>
                 <a:cs typeface="Georgia" pitchFamily="34" charset="-120"/>
               </a:rPr>
-              <a:t>1 yil</a:t>
+              <a:t>1 yr</a:t>
             </a:r>
             <a:endParaRPr lang="en-US" sz="1600" dirty="0"/>
           </a:p>
@@ -2637,7 +2637,7 @@
                 <a:ea typeface="Calibri" pitchFamily="34" charset="-122"/>
                 <a:cs typeface="Calibri" pitchFamily="34" charset="-120"/>
               </a:rPr>
-              <a:t>Milliy joriy etish</a:t>
+              <a:t>National rollout</a:t>
             </a:r>
             <a:endParaRPr lang="en-US" sz="1250" dirty="0"/>
           </a:p>
@@ -2701,7 +2701,7 @@
                 <a:ea typeface="Georgia" pitchFamily="34" charset="-122"/>
                 <a:cs typeface="Georgia" pitchFamily="34" charset="-120"/>
               </a:rPr>
-              <a:t>3 yil</a:t>
+              <a:t>3 yr</a:t>
             </a:r>
             <a:endParaRPr lang="en-US" sz="1600" dirty="0"/>
           </a:p>
@@ -2743,7 +2743,7 @@
                 <a:ea typeface="Calibri" pitchFamily="34" charset="-122"/>
                 <a:cs typeface="Calibri" pitchFamily="34" charset="-120"/>
               </a:rPr>
-              <a:t>Mintaqa · MO/MDH</a:t>
+              <a:t>Region · C. Asia / CIS</a:t>
             </a:r>
             <a:endParaRPr lang="en-US" sz="1250" dirty="0"/>
           </a:p>
@@ -2892,7 +2892,7 @@
                 <a:ea typeface="Calibri" pitchFamily="34" charset="-122"/>
                 <a:cs typeface="Calibri" pitchFamily="34" charset="-120"/>
               </a:rPr>
-              <a:t>JAMOA</a:t>
+              <a:t>TEAM</a:t>
             </a:r>
             <a:endParaRPr lang="en-US" sz="1250" dirty="0"/>
           </a:p>
@@ -2934,7 +2934,7 @@
                 <a:ea typeface="Georgia" pitchFamily="34" charset="-122"/>
                 <a:cs typeface="Georgia" pitchFamily="34" charset="-120"/>
               </a:rPr>
-              <a:t>Tez ishlaydigan jamoa — va Oliy Sud.</a:t>
+              <a:t>A team that ships fast — and the Supreme Court.</a:t>
             </a:r>
             <a:endParaRPr lang="en-US" sz="3100" dirty="0"/>
           </a:p>
@@ -3084,7 +3084,7 @@
                 <a:ea typeface="Calibri" pitchFamily="34" charset="-122"/>
                 <a:cs typeface="Calibri" pitchFamily="34" charset="-120"/>
               </a:rPr>
-              <a:t>Asoschi / Jamoa rahbari — O'zbekistondagi birinchi Cursor Ambassador. Horyco (restoran AI OS) va Notiky (AI mahsulot miyasi)'ni yakka o'zi qurgan.</a:t>
+              <a:t>Founder / Lead — first Cursor Ambassador in Uzbekistan. Built Horyco (restaurant AI OS) and Notiky (AI product brain) solo.</a:t>
             </a:r>
             <a:endParaRPr lang="en-US" sz="2100" dirty="0"/>
           </a:p>
@@ -3288,7 +3288,7 @@
                 <a:ea typeface="Calibri" pitchFamily="34" charset="-122"/>
                 <a:cs typeface="Calibri" pitchFamily="34" charset="-120"/>
               </a:rPr>
-              <a:t>Dizayn (UI/UX)</a:t>
+              <a:t>Design (UI/UX)</a:t>
             </a:r>
             <a:endParaRPr lang="en-US" sz="1400" dirty="0"/>
           </a:p>
@@ -3356,7 +3356,7 @@
                 <a:ea typeface="Calibri" pitchFamily="34" charset="-122"/>
                 <a:cs typeface="Calibri" pitchFamily="34" charset="-120"/>
               </a:rPr>
-              <a:t>Soha / Yurist</a:t>
+              <a:t>Domain / Legal</a:t>
             </a:r>
             <a:endParaRPr lang="en-US" sz="1400" dirty="0"/>
           </a:p>
@@ -3417,7 +3417,7 @@
                 <a:ea typeface="Calibri" pitchFamily="34" charset="-122"/>
                 <a:cs typeface="Calibri" pitchFamily="34" charset="-120"/>
               </a:rPr>
-              <a:t>Maslahatchilar:  </a:t>
+              <a:t>Advisors:  </a:t>
             </a:r>
             <a:pPr algn="ctr" indent="0" marL="0">
               <a:buNone/>
@@ -3431,7 +3431,7 @@
                 <a:ea typeface="Calibri" pitchFamily="34" charset="-122"/>
                 <a:cs typeface="Calibri" pitchFamily="34" charset="-120"/>
               </a:rPr>
-              <a:t>Oliy Sud (O'zbekiston Respublikasi Oliy sudi)</a:t>
+              <a:t>Oliy Sud — the Supreme Court of the Republic of Uzbekistan</a:t>
             </a:r>
             <a:endParaRPr lang="en-US" sz="1600" dirty="0"/>
           </a:p>
@@ -3603,7 +3603,7 @@
                 <a:ea typeface="Georgia" pitchFamily="34" charset="-122"/>
                 <a:cs typeface="Georgia" pitchFamily="34" charset="-120"/>
               </a:rPr>
-              <a:t>Bizga sarmoya kerak emas.</a:t>
+              <a:t>We don't need funding.</a:t>
             </a:r>
             <a:endParaRPr lang="en-US" sz="4000" dirty="0"/>
           </a:p>
@@ -3623,7 +3623,7 @@
                 <a:ea typeface="Georgia" pitchFamily="34" charset="-122"/>
                 <a:cs typeface="Georgia" pitchFamily="34" charset="-120"/>
               </a:rPr>
-              <a:t>Bizga g'alaba kerak.</a:t>
+              <a:t>We need to win.</a:t>
             </a:r>
             <a:endParaRPr lang="en-US" sz="4000" dirty="0"/>
           </a:p>
@@ -3665,7 +3665,7 @@
                 <a:ea typeface="Calibri" pitchFamily="34" charset="-122"/>
                 <a:cs typeface="Calibri" pitchFamily="34" charset="-120"/>
               </a:rPr>
-              <a:t>Chunki g'alaba — davlat Areeza'ni qabul qilib, yiliga millionlab fuqaroga adolat eshigini ochishidir.</a:t>
+              <a:t>Because winning means the government adopts Areeza — opening the door to justice for millions of citizens a year.</a:t>
             </a:r>
             <a:endParaRPr lang="en-US" sz="1800" dirty="0"/>
           </a:p>
@@ -3718,7 +3718,7 @@
                 <a:ea typeface="Calibri" pitchFamily="34" charset="-122"/>
                 <a:cs typeface="Calibri" pitchFamily="34" charset="-120"/>
               </a:rPr>
-              <a:t>   ·   Sudga tayyor ariza — bir gapdan.   ·   #MilliyAIXakaton  #AndijonAI</a:t>
+              <a:t>   ·   A court-ready filing, from a single sentence.   ·   #NationalAIHackathon  #AndijanAI</a:t>
             </a:r>
             <a:endParaRPr lang="en-US" sz="1300" dirty="0"/>
           </a:p>
@@ -3789,7 +3789,7 @@
                 <a:ea typeface="Calibri" pitchFamily="34" charset="-122"/>
                 <a:cs typeface="Calibri" pitchFamily="34" charset="-120"/>
               </a:rPr>
-              <a:t>MUAMMO</a:t>
+              <a:t>THE PROBLEM</a:t>
             </a:r>
             <a:endParaRPr lang="en-US" sz="1250" dirty="0"/>
           </a:p>
@@ -3831,7 +3831,7 @@
                 <a:ea typeface="Georgia" pitchFamily="34" charset="-122"/>
                 <a:cs typeface="Georgia" pitchFamily="34" charset="-120"/>
               </a:rPr>
-              <a:t>Sudlar onlayn bo'ldi. Adolat — yo'q.</a:t>
+              <a:t>Courts went online. Justice didn't.</a:t>
             </a:r>
             <a:endParaRPr lang="en-US" sz="3100" dirty="0"/>
           </a:p>
@@ -3928,7 +3928,7 @@
                 <a:ea typeface="Calibri" pitchFamily="34" charset="-122"/>
                 <a:cs typeface="Calibri" pitchFamily="34" charset="-120"/>
               </a:rPr>
-              <a:t>FUQARO YOLG'IZ</a:t>
+              <a:t>THE CITIZEN IS ALONE</a:t>
             </a:r>
             <a:endParaRPr lang="en-US" sz="1300" dirty="0"/>
           </a:p>
@@ -4009,7 +4009,7 @@
                 <a:ea typeface="Calibri" pitchFamily="34" charset="-122"/>
                 <a:cs typeface="Calibri" pitchFamily="34" charset="-120"/>
               </a:rPr>
-              <a:t>advokat narxi — eng kam oylik ($100/oy) dan ham qimmat. Qaysi ariza, qaysi shakl, qaysi modda — bilmaydi, va protsedura xatosi uchun rad etiladi.</a:t>
+              <a:t>for a lawyer — more than the $100/mo minimum wage. People don't know which claim, which form, or which code, so filings are rejected for procedural mistakes.</a:t>
             </a:r>
             <a:endParaRPr lang="en-US" sz="1500" dirty="0"/>
           </a:p>
@@ -4048,7 +4048,7 @@
                 <a:ea typeface="Calibri" pitchFamily="34" charset="-122"/>
                 <a:cs typeface="Calibri" pitchFamily="34" charset="-120"/>
               </a:rPr>
-              <a:t>SUDLAR CHO'KMOQDA</a:t>
+              <a:t>THE COURTS ARE DROWNING</a:t>
             </a:r>
             <a:endParaRPr lang="en-US" sz="1300" dirty="0"/>
           </a:p>
@@ -4101,7 +4101,7 @@
                 <a:ea typeface="Georgia" pitchFamily="34" charset="-122"/>
                 <a:cs typeface="Georgia" pitchFamily="34" charset="-120"/>
               </a:rPr>
-              <a:t> / oy</a:t>
+              <a:t> / mo</a:t>
             </a:r>
             <a:endParaRPr lang="en-US" sz="4600" dirty="0"/>
           </a:p>
@@ -4143,7 +4143,7 @@
                 <a:ea typeface="Calibri" pitchFamily="34" charset="-122"/>
                 <a:cs typeface="Calibri" pitchFamily="34" charset="-120"/>
               </a:rPr>
-              <a:t>bir sudyaga to'g'ri keladigan fuqarolik ishi — xalqaro me'yor 16 ta. Yiliga 2 mln+ fuqarolik ishi (+50%). Oliy Sud buni "real bo'lmagan rejim" deydi.</a:t>
+              <a:t>civil cases per judge — vs. a global norm of 16. 2M+ civil cases a year (+50% YoY). The Supreme Court itself calls it "an unrealistic regime."</a:t>
             </a:r>
             <a:endParaRPr lang="en-US" sz="1500" dirty="0"/>
           </a:p>
@@ -4182,7 +4182,7 @@
                 <a:ea typeface="Calibri" pitchFamily="34" charset="-122"/>
                 <a:cs typeface="Calibri" pitchFamily="34" charset="-120"/>
               </a:rPr>
-              <a:t>Bitta ildiz:  </a:t>
+              <a:t>One root cause:  </a:t>
             </a:r>
             <a:pPr algn="ctr" indent="0" marL="0">
               <a:buNone/>
@@ -4196,7 +4196,7 @@
                 <a:ea typeface="Calibri" pitchFamily="34" charset="-122"/>
                 <a:cs typeface="Calibri" pitchFamily="34" charset="-120"/>
               </a:rPr>
-              <a:t>odam o'z hayotiy muammosini to'g'ri yuridik tartibga sola olmaydi — natijada fuqaro chetda qoladi, sud esa cho'kadi.</a:t>
+              <a:t>people can't translate a life problem into the right legal procedure — so citizens are shut out, and courts drown in messy filings.</a:t>
             </a:r>
             <a:endParaRPr lang="en-US" sz="1450" dirty="0"/>
           </a:p>
@@ -4345,7 +4345,7 @@
                 <a:ea typeface="Calibri" pitchFamily="34" charset="-122"/>
                 <a:cs typeface="Calibri" pitchFamily="34" charset="-120"/>
               </a:rPr>
-              <a:t>NEGA AYNAN HOZIR</a:t>
+              <a:t>WHY NOW</a:t>
             </a:r>
             <a:endParaRPr lang="en-US" sz="1250" dirty="0"/>
           </a:p>
@@ -4387,7 +4387,7 @@
                 <a:ea typeface="Georgia" pitchFamily="34" charset="-122"/>
                 <a:cs typeface="Georgia" pitchFamily="34" charset="-120"/>
               </a:rPr>
-              <a:t>Bu imkoniyat 18 oy oldin mavjud emas edi.</a:t>
+              <a:t>This was impossible 18 months ago.</a:t>
             </a:r>
             <a:endParaRPr lang="en-US" sz="3100" dirty="0"/>
           </a:p>
@@ -4506,7 +4506,7 @@
               <a:buNone/>
             </a:pPr>
             <a:r>
-              <a:rPr lang="en-US" sz="1750" b="1" dirty="0">
+              <a:rPr lang="en-US" sz="1700" b="1" dirty="0">
                 <a:solidFill>
                   <a:srgbClr val="FFFFFF"/>
                 </a:solidFill>
@@ -4514,9 +4514,9 @@
                 <a:ea typeface="Georgia" pitchFamily="34" charset="-122"/>
                 <a:cs typeface="Georgia" pitchFamily="34" charset="-120"/>
               </a:rPr>
-              <a:t>Elektron ariza — majburiy</a:t>
-            </a:r>
-            <a:endParaRPr lang="en-US" sz="1750" dirty="0"/>
+              <a:t>E-filing just became mandatory</a:t>
+            </a:r>
+            <a:endParaRPr lang="en-US" sz="1700" dirty="0"/>
           </a:p>
         </p:txBody>
       </p:sp>
@@ -4556,7 +4556,7 @@
                 <a:ea typeface="Calibri" pitchFamily="34" charset="-122"/>
                 <a:cs typeface="Calibri" pitchFamily="34" charset="-120"/>
               </a:rPr>
-              <a:t>Prezident farmoni (2025-yil avg): sudga arizalar faqat elektron tarzda.</a:t>
+              <a:t>Presidential decree (Aug 2025): court applications are now electronic-only.</a:t>
             </a:r>
             <a:endParaRPr lang="en-US" sz="1300" dirty="0"/>
           </a:p>
@@ -4675,7 +4675,7 @@
               <a:buNone/>
             </a:pPr>
             <a:r>
-              <a:rPr lang="en-US" sz="1750" b="1" dirty="0">
+              <a:rPr lang="en-US" sz="1700" b="1" dirty="0">
                 <a:solidFill>
                   <a:srgbClr val="FFFFFF"/>
                 </a:solidFill>
@@ -4683,9 +4683,9 @@
                 <a:ea typeface="Georgia" pitchFamily="34" charset="-122"/>
                 <a:cs typeface="Georgia" pitchFamily="34" charset="-120"/>
               </a:rPr>
-              <a:t>Davlat sudga AI joriy qilmoqda</a:t>
-            </a:r>
-            <a:endParaRPr lang="en-US" sz="1750" dirty="0"/>
+              <a:t>The state is putting AI in courts</a:t>
+            </a:r>
+            <a:endParaRPr lang="en-US" sz="1700" dirty="0"/>
           </a:p>
         </p:txBody>
       </p:sp>
@@ -4725,7 +4725,7 @@
                 <a:ea typeface="Calibri" pitchFamily="34" charset="-122"/>
                 <a:cs typeface="Calibri" pitchFamily="34" charset="-120"/>
               </a:rPr>
-              <a:t>my.sud.uz'da AI yordamchi, prognoz, avto-hujjat — tayyor xaridor va e'tirof.</a:t>
+              <a:t>An AI assistant on my.sud.uz, outcome prediction, auto-drafting — a built-in buyer and endorsement.</a:t>
             </a:r>
             <a:endParaRPr lang="en-US" sz="1300" dirty="0"/>
           </a:p>
@@ -4844,7 +4844,7 @@
               <a:buNone/>
             </a:pPr>
             <a:r>
-              <a:rPr lang="en-US" sz="1750" b="1" dirty="0">
+              <a:rPr lang="en-US" sz="1700" b="1" dirty="0">
                 <a:solidFill>
                   <a:srgbClr val="FFFFFF"/>
                 </a:solidFill>
@@ -4852,9 +4852,9 @@
                 <a:ea typeface="Georgia" pitchFamily="34" charset="-122"/>
                 <a:cs typeface="Georgia" pitchFamily="34" charset="-120"/>
               </a:rPr>
-              <a:t>LLM modellari yetildi</a:t>
-            </a:r>
-            <a:endParaRPr lang="en-US" sz="1750" dirty="0"/>
+              <a:t>LLMs crossed the threshold</a:t>
+            </a:r>
+            <a:endParaRPr lang="en-US" sz="1700" dirty="0"/>
           </a:p>
         </p:txBody>
       </p:sp>
@@ -4894,7 +4894,7 @@
                 <a:ea typeface="Calibri" pitchFamily="34" charset="-122"/>
                 <a:cs typeface="Calibri" pitchFamily="34" charset="-120"/>
               </a:rPr>
-              <a:t>Endi xom hikoyani yuridik tilga aylantirish mumkin — biroq xom AI xato qiladi; biz tekshiramiz.</a:t>
+              <a:t>Models can now turn a messy story into legal language — but raw AI hallucinates; we validate against real forms.</a:t>
             </a:r>
             <a:endParaRPr lang="en-US" sz="1300" dirty="0"/>
           </a:p>
@@ -5013,7 +5013,7 @@
               <a:buNone/>
             </a:pPr>
             <a:r>
-              <a:rPr lang="en-US" sz="1750" b="1" dirty="0">
+              <a:rPr lang="en-US" sz="1700" b="1" dirty="0">
                 <a:solidFill>
                   <a:srgbClr val="FFFFFF"/>
                 </a:solidFill>
@@ -5021,9 +5021,9 @@
                 <a:ea typeface="Georgia" pitchFamily="34" charset="-122"/>
                 <a:cs typeface="Georgia" pitchFamily="34" charset="-120"/>
               </a:rPr>
-              <a:t>Raqamli O'zbekiston 2030</a:t>
-            </a:r>
-            <a:endParaRPr lang="en-US" sz="1750" dirty="0"/>
+              <a:t>Digital Uzbekistan 2030</a:t>
+            </a:r>
+            <a:endParaRPr lang="en-US" sz="1700" dirty="0"/>
           </a:p>
         </p:txBody>
       </p:sp>
@@ -5063,7 +5063,7 @@
                 <a:ea typeface="Calibri" pitchFamily="34" charset="-122"/>
                 <a:cs typeface="Calibri" pitchFamily="34" charset="-120"/>
               </a:rPr>
-              <a:t>16 mln+ raqamli davlat xizmati (2025, 1-yarim yil). Fuqaro ham tayyor.</a:t>
+              <a:t>16M+ digital government services in H1 2025. Citizens are ready too.</a:t>
             </a:r>
             <a:endParaRPr lang="en-US" sz="1300" dirty="0"/>
           </a:p>
@@ -5212,7 +5212,7 @@
                 <a:ea typeface="Calibri" pitchFamily="34" charset="-122"/>
                 <a:cs typeface="Calibri" pitchFamily="34" charset="-120"/>
               </a:rPr>
-              <a:t>YECHIM</a:t>
+              <a:t>THE SOLUTION</a:t>
             </a:r>
             <a:endParaRPr lang="en-US" sz="1250" dirty="0"/>
           </a:p>
@@ -5254,7 +5254,7 @@
                 <a:ea typeface="Georgia" pitchFamily="34" charset="-122"/>
                 <a:cs typeface="Georgia" pitchFamily="34" charset="-120"/>
               </a:rPr>
-              <a:t>Muammodan — sudga tayyor arizagacha.</a:t>
+              <a:t>From a problem to a court-ready filing.</a:t>
             </a:r>
             <a:endParaRPr lang="en-US" sz="3100" dirty="0"/>
           </a:p>
@@ -5381,7 +5381,7 @@
                 <a:ea typeface="Calibri" pitchFamily="34" charset="-122"/>
                 <a:cs typeface="Calibri" pitchFamily="34" charset="-120"/>
               </a:rPr>
-              <a:t>Tasvirlang</a:t>
+              <a:t>Describe</a:t>
             </a:r>
             <a:endParaRPr lang="en-US" sz="1350" dirty="0"/>
           </a:p>
@@ -5547,7 +5547,7 @@
                 <a:ea typeface="Calibri" pitchFamily="34" charset="-122"/>
                 <a:cs typeface="Calibri" pitchFamily="34" charset="-120"/>
               </a:rPr>
-              <a:t>Tasniflang</a:t>
+              <a:t>Classify</a:t>
             </a:r>
             <a:endParaRPr lang="en-US" sz="1350" dirty="0"/>
           </a:p>
@@ -5713,7 +5713,7 @@
                 <a:ea typeface="Calibri" pitchFamily="34" charset="-122"/>
                 <a:cs typeface="Calibri" pitchFamily="34" charset="-120"/>
               </a:rPr>
-              <a:t>Yo'naltiring</a:t>
+              <a:t>Route</a:t>
             </a:r>
             <a:endParaRPr lang="en-US" sz="1350" dirty="0"/>
           </a:p>
@@ -5879,7 +5879,7 @@
                 <a:ea typeface="Calibri" pitchFamily="34" charset="-122"/>
                 <a:cs typeface="Calibri" pitchFamily="34" charset="-120"/>
               </a:rPr>
-              <a:t>Tayyorlang</a:t>
+              <a:t>Draft</a:t>
             </a:r>
             <a:endParaRPr lang="en-US" sz="1350" dirty="0"/>
           </a:p>
@@ -6045,7 +6045,7 @@
                 <a:ea typeface="Calibri" pitchFamily="34" charset="-122"/>
                 <a:cs typeface="Calibri" pitchFamily="34" charset="-120"/>
               </a:rPr>
-              <a:t>Tekshiring</a:t>
+              <a:t>Validate</a:t>
             </a:r>
             <a:endParaRPr lang="en-US" sz="1350" dirty="0"/>
           </a:p>
@@ -6211,7 +6211,7 @@
                 <a:ea typeface="Calibri" pitchFamily="34" charset="-122"/>
                 <a:cs typeface="Calibri" pitchFamily="34" charset="-120"/>
               </a:rPr>
-              <a:t>Topshiring</a:t>
+              <a:t>File</a:t>
             </a:r>
             <a:endParaRPr lang="en-US" sz="1350" dirty="0"/>
           </a:p>
@@ -6250,7 +6250,7 @@
                 <a:ea typeface="Calibri" pitchFamily="34" charset="-122"/>
                 <a:cs typeface="Calibri" pitchFamily="34" charset="-120"/>
               </a:rPr>
-              <a:t>Bu chatbot emas. </a:t>
+              <a:t>Not a chatbot. </a:t>
             </a:r>
             <a:pPr algn="ctr" indent="0" marL="0">
               <a:buNone/>
@@ -6264,7 +6264,7 @@
                 <a:ea typeface="Calibri" pitchFamily="34" charset="-122"/>
                 <a:cs typeface="Calibri" pitchFamily="34" charset="-120"/>
               </a:rPr>
-              <a:t>Bu ishni oxirigacha — to'g'ri yo'nalish, sudga tayyor hujjat, validatsiya va topshirish — bajaradigan platforma.</a:t>
+              <a:t>A platform that completes the filing — correct route, court-ready document, validation, and submission guidance.</a:t>
             </a:r>
             <a:endParaRPr lang="en-US" sz="1600" dirty="0"/>
           </a:p>
@@ -6303,7 +6303,7 @@
                 <a:ea typeface="Georgia" pitchFamily="34" charset="-122"/>
                 <a:cs typeface="Georgia" pitchFamily="34" charset="-120"/>
               </a:rPr>
-              <a:t>“Tekshiruv” bosqichi — rad etishdan oldin xatolarni ushlaydigan asosiy ustunligimiz.</a:t>
+              <a:t>The “Validate” step catches the errors that cause rejection — before filing. That's our core edge.</a:t>
             </a:r>
             <a:endParaRPr lang="en-US" sz="1400" dirty="0"/>
           </a:p>
@@ -6452,7 +6452,7 @@
                 <a:ea typeface="Calibri" pitchFamily="34" charset="-122"/>
                 <a:cs typeface="Calibri" pitchFamily="34" charset="-120"/>
               </a:rPr>
-              <a:t>JONLI DEMO</a:t>
+              <a:t>LIVE DEMO</a:t>
             </a:r>
             <a:endParaRPr lang="en-US" sz="1250" dirty="0"/>
           </a:p>
@@ -6486,7 +6486,7 @@
               <a:buNone/>
             </a:pPr>
             <a:r>
-              <a:rPr lang="en-US" sz="2700" b="1" dirty="0">
+              <a:rPr lang="en-US" sz="2600" b="1" dirty="0">
                 <a:solidFill>
                   <a:srgbClr val="FFFFFF"/>
                 </a:solidFill>
@@ -6494,9 +6494,9 @@
                 <a:ea typeface="Georgia" pitchFamily="34" charset="-122"/>
                 <a:cs typeface="Georgia" pitchFamily="34" charset="-120"/>
               </a:rPr>
-              <a:t>«Oyligimni to'lashmadi» → sudga tayyor ariza. 2 daqiqada.</a:t>
-            </a:r>
-            <a:endParaRPr lang="en-US" sz="2700" dirty="0"/>
+              <a:t>“They didn't pay my salary” → a court-ready filing. In 2 minutes.</a:t>
+            </a:r>
+            <a:endParaRPr lang="en-US" sz="2600" dirty="0"/>
           </a:p>
         </p:txBody>
       </p:sp>
@@ -6562,7 +6562,7 @@
                 <a:ea typeface="Calibri" pitchFamily="34" charset="-122"/>
                 <a:cs typeface="Calibri" pitchFamily="34" charset="-120"/>
               </a:rPr>
-              <a:t>KIRITISH</a:t>
+              <a:t>INPUT</a:t>
             </a:r>
             <a:endParaRPr lang="en-US" sz="1200" dirty="0"/>
           </a:p>
@@ -6628,7 +6628,7 @@
                 <a:ea typeface="Calibri" pitchFamily="34" charset="-122"/>
                 <a:cs typeface="Calibri" pitchFamily="34" charset="-120"/>
               </a:rPr>
-              <a:t>“Ish beruvchim 2 oydan beri oyligimni to'lamayapti.”</a:t>
+              <a:t>“My employer hasn't paid my salary for two months.”</a:t>
             </a:r>
             <a:endParaRPr lang="en-US" sz="1500" dirty="0"/>
           </a:p>
@@ -6667,7 +6667,7 @@
                 <a:ea typeface="Calibri" pitchFamily="34" charset="-122"/>
                 <a:cs typeface="Calibri" pitchFamily="34" charset="-120"/>
               </a:rPr>
-              <a:t>oddiy o'zbek tilida</a:t>
+              <a:t>plain language — Uzbek or Russian</a:t>
             </a:r>
             <a:endParaRPr lang="en-US" sz="1200" dirty="0"/>
           </a:p>
@@ -6813,7 +6813,7 @@
                 <a:ea typeface="Calibri" pitchFamily="34" charset="-122"/>
                 <a:cs typeface="Calibri" pitchFamily="34" charset="-120"/>
               </a:rPr>
-              <a:t>(ish haqini undirish to'g'risida)</a:t>
+              <a:t>statement of claim — wage recovery</a:t>
             </a:r>
             <a:endParaRPr lang="en-US" sz="1100" dirty="0"/>
           </a:p>
@@ -6852,7 +6852,7 @@
                 <a:ea typeface="Calibri" pitchFamily="34" charset="-122"/>
                 <a:cs typeface="Calibri" pitchFamily="34" charset="-120"/>
               </a:rPr>
-              <a:t>Sud:  Andijon tuman fuqarolik sudi</a:t>
+              <a:t>Court:  Andijan district civil court</a:t>
             </a:r>
             <a:endParaRPr lang="en-US" sz="1250" dirty="0"/>
           </a:p>
@@ -6891,7 +6891,7 @@
                 <a:ea typeface="Calibri" pitchFamily="34" charset="-122"/>
                 <a:cs typeface="Calibri" pitchFamily="34" charset="-120"/>
               </a:rPr>
-              <a:t>Asos:  Mehnat kodeksi · FPK 188, 189, 191</a:t>
+              <a:t>Basis:  Labor Code · CPC art. 188, 189, 191</a:t>
             </a:r>
             <a:endParaRPr lang="en-US" sz="1250" dirty="0"/>
           </a:p>
@@ -6930,7 +6930,7 @@
                 <a:ea typeface="Calibri" pitchFamily="34" charset="-122"/>
                 <a:cs typeface="Calibri" pitchFamily="34" charset="-120"/>
               </a:rPr>
-              <a:t>Davlat boji:  ozod (mehnat nizosi)</a:t>
+              <a:t>State fee:  exempt (labor dispute)</a:t>
             </a:r>
             <a:endParaRPr lang="en-US" sz="1250" dirty="0"/>
           </a:p>
@@ -7008,7 +7008,7 @@
                 <a:ea typeface="Calibri" pitchFamily="34" charset="-122"/>
                 <a:cs typeface="Calibri" pitchFamily="34" charset="-120"/>
               </a:rPr>
-              <a:t>Sud to'g'ri aniqlandi</a:t>
+              <a:t>Court correctly identified</a:t>
             </a:r>
             <a:endParaRPr lang="en-US" sz="1250" dirty="0"/>
           </a:p>
@@ -7086,7 +7086,7 @@
                 <a:ea typeface="Calibri" pitchFamily="34" charset="-122"/>
                 <a:cs typeface="Calibri" pitchFamily="34" charset="-120"/>
               </a:rPr>
-              <a:t>Ariza summasi ko'rsatilgan</a:t>
+              <a:t>Claim amount present</a:t>
             </a:r>
             <a:endParaRPr lang="en-US" sz="1250" dirty="0"/>
           </a:p>
@@ -7164,7 +7164,7 @@
                 <a:ea typeface="Calibri" pitchFamily="34" charset="-122"/>
                 <a:cs typeface="Calibri" pitchFamily="34" charset="-120"/>
               </a:rPr>
-              <a:t>Shartnoma nusxasini ilova qiling</a:t>
+              <a:t>Attach employment contract</a:t>
             </a:r>
             <a:endParaRPr lang="en-US" sz="1250" dirty="0"/>
           </a:p>
@@ -7203,7 +7203,7 @@
                 <a:ea typeface="Georgia" pitchFamily="34" charset="-122"/>
                 <a:cs typeface="Georgia" pitchFamily="34" charset="-120"/>
               </a:rPr>
-              <a:t>Hujjat Oliy Sud maslahatchilari bilan tekshirilgan.</a:t>
+              <a:t>The generated document is verified with our Supreme Court advisors.</a:t>
             </a:r>
             <a:endParaRPr lang="en-US" sz="1300" dirty="0"/>
           </a:p>
@@ -7352,7 +7352,7 @@
                 <a:ea typeface="Calibri" pitchFamily="34" charset="-122"/>
                 <a:cs typeface="Calibri" pitchFamily="34" charset="-120"/>
               </a:rPr>
-              <a:t>BOZOR</a:t>
+              <a:t>MARKET</a:t>
             </a:r>
             <a:endParaRPr lang="en-US" sz="1250" dirty="0"/>
           </a:p>
@@ -7394,7 +7394,7 @@
                 <a:ea typeface="Georgia" pitchFamily="34" charset="-122"/>
                 <a:cs typeface="Georgia" pitchFamily="34" charset="-120"/>
               </a:rPr>
-              <a:t>Andijondan boshlanadi. Dunyo — oldinda.</a:t>
+              <a:t>Starts in Andijan. The world is ahead.</a:t>
             </a:r>
             <a:endParaRPr lang="en-US" sz="3100" dirty="0"/>
           </a:p>
@@ -7504,7 +7504,7 @@
                 <a:ea typeface="Calibri" pitchFamily="34" charset="-122"/>
                 <a:cs typeface="Calibri" pitchFamily="34" charset="-120"/>
               </a:rPr>
-              <a:t>Global legaltech $29.8B → $73B (2035) · 1.5 mlrd odam adolatga muhtoj</a:t>
+              <a:t>Global legaltech $29.8B → $73B (2035)  ·  1.5B people with unmet justice needs</a:t>
             </a:r>
             <a:endParaRPr lang="en-US" sz="1350" dirty="0"/>
           </a:p>
@@ -7614,7 +7614,7 @@
                 <a:ea typeface="Calibri" pitchFamily="34" charset="-122"/>
                 <a:cs typeface="Calibri" pitchFamily="34" charset="-120"/>
               </a:rPr>
-              <a:t>Markaziy Osiyo + MDH — fuqarolik huquqi tizimlari · 250–300 mln aholi</a:t>
+              <a:t>Civil-law digitizing-justice markets — Central Asia + CIS  ·  250–300M people</a:t>
             </a:r>
             <a:endParaRPr lang="en-US" sz="1350" dirty="0"/>
           </a:p>
@@ -7724,7 +7724,7 @@
                 <a:ea typeface="Calibri" pitchFamily="34" charset="-122"/>
                 <a:cs typeface="Calibri" pitchFamily="34" charset="-120"/>
               </a:rPr>
-              <a:t>O'zbekiston — yiliga 2 mln+ fuqarolik ishi, +50% · davlat onlayn'ga majburlamoqda</a:t>
+              <a:t>Uzbekistan — 2M+ civil cases / year, +50% YoY  ·  a market the state is forcing online</a:t>
             </a:r>
             <a:endParaRPr lang="en-US" sz="1350" dirty="0"/>
           </a:p>
@@ -7763,7 +7763,7 @@
                 <a:ea typeface="Calibri" pitchFamily="34" charset="-122"/>
                 <a:cs typeface="Calibri" pitchFamily="34" charset="-120"/>
               </a:rPr>
-              <a:t>1.5 mlrd (TAM) → 300 mln fuqarolik-huquq mintaqasi (SAM) → 2 mln+ ariza/yil (SOM). Davlat o'zi onlayn'ga majburlayotgan bozor.</a:t>
+              <a:t>1.5B underserved (TAM) → 300M in our civil-law region (SAM) → 2M+ filings/year, growing 50% (SOM).</a:t>
             </a:r>
             <a:endParaRPr lang="en-US" sz="1250" dirty="0"/>
           </a:p>
@@ -7912,7 +7912,7 @@
                 <a:ea typeface="Calibri" pitchFamily="34" charset="-122"/>
                 <a:cs typeface="Calibri" pitchFamily="34" charset="-120"/>
               </a:rPr>
-              <a:t>RAQOBAT</a:t>
+              <a:t>COMPETITION</a:t>
             </a:r>
             <a:endParaRPr lang="en-US" sz="1250" dirty="0"/>
           </a:p>
@@ -7954,7 +7954,7 @@
                 <a:ea typeface="Georgia" pitchFamily="34" charset="-122"/>
                 <a:cs typeface="Georgia" pitchFamily="34" charset="-120"/>
               </a:rPr>
-              <a:t>Hammasini bajaradigan yagona yechim.</a:t>
+              <a:t>The only solution that does it all.</a:t>
             </a:r>
             <a:endParaRPr lang="en-US" sz="3100" dirty="0"/>
           </a:p>
@@ -8196,7 +8196,7 @@
                           <a:ea typeface="Calibri" pitchFamily="34" charset="-122"/>
                           <a:cs typeface="Calibri" pitchFamily="34" charset="-120"/>
                         </a:rPr>
-                        <a:t>Advokat</a:t>
+                        <a:t>Lawyer</a:t>
                       </a:r>
                       <a:endParaRPr lang="en-US" sz="1350" dirty="0">
                         <a:latin typeface="Calibri" charset="0"/>
@@ -8334,7 +8334,7 @@
                           <a:ea typeface="Calibri" pitchFamily="34" charset="-122"/>
                           <a:cs typeface="Calibri" pitchFamily="34" charset="-120"/>
                         </a:rPr>
-                        <a:t>Oddiy tilni tushunadi</a:t>
+                        <a:t>Understands plain language (UZ/RU)</a:t>
                       </a:r>
                       <a:endParaRPr lang="en-US" sz="1300" dirty="0">
                         <a:latin typeface="Calibri" charset="0"/>
@@ -8676,7 +8676,7 @@
                           <a:ea typeface="Calibri" pitchFamily="34" charset="-122"/>
                           <a:cs typeface="Calibri" pitchFamily="34" charset="-120"/>
                         </a:rPr>
-                        <a:t>To'g'ri yuridik yo'nalish</a:t>
+                        <a:t>Picks the correct legal route</a:t>
                       </a:r>
                       <a:endParaRPr lang="en-US" sz="1300" dirty="0">
                         <a:latin typeface="Calibri" charset="0"/>
@@ -9018,7 +9018,7 @@
                           <a:ea typeface="Calibri" pitchFamily="34" charset="-122"/>
                           <a:cs typeface="Calibri" pitchFamily="34" charset="-120"/>
                         </a:rPr>
-                        <a:t>Sudga tayyor hujjat</a:t>
+                        <a:t>Court-ready document</a:t>
                       </a:r>
                       <a:endParaRPr lang="en-US" sz="1300" dirty="0">
                         <a:latin typeface="Calibri" charset="0"/>
@@ -9360,7 +9360,7 @@
                           <a:ea typeface="Calibri" pitchFamily="34" charset="-122"/>
                           <a:cs typeface="Calibri" pitchFamily="34" charset="-120"/>
                         </a:rPr>
-                        <a:t>Rad etishdan himoya</a:t>
+                        <a:t>Validates against rejection</a:t>
                       </a:r>
                       <a:endParaRPr lang="en-US" sz="1300" dirty="0">
                         <a:latin typeface="Calibri" charset="0"/>
@@ -9702,7 +9702,7 @@
                           <a:ea typeface="Calibri" pitchFamily="34" charset="-122"/>
                           <a:cs typeface="Calibri" pitchFamily="34" charset="-120"/>
                         </a:rPr>
-                        <a:t>O'zbek qonunlariga xos</a:t>
+                        <a:t>Local-law-specific</a:t>
                       </a:r>
                       <a:endParaRPr lang="en-US" sz="1300" dirty="0">
                         <a:latin typeface="Calibri" charset="0"/>
@@ -10405,7 +10405,7 @@
                 <a:ea typeface="Calibri" pitchFamily="34" charset="-122"/>
                 <a:cs typeface="Calibri" pitchFamily="34" charset="-120"/>
               </a:rPr>
-              <a:t>DoNotPay bu yerda ishlay olmaydi</a:t>
+              <a:t>DoNotPay can't even run here</a:t>
             </a:r>
             <a:pPr algn="ctr" indent="0" marL="0">
               <a:buNone/>
@@ -10419,7 +10419,7 @@
                 <a:ea typeface="Calibri" pitchFamily="34" charset="-122"/>
                 <a:cs typeface="Calibri" pitchFamily="34" charset="-120"/>
               </a:rPr>
-              <a:t> (umumiy huquq tizimi uchun, FTC jarimasi bilan).  </a:t>
+              <a:t> (common-law only, FTC-fined).  </a:t>
             </a:r>
             <a:pPr algn="ctr" indent="0" marL="0">
               <a:buNone/>
@@ -10433,7 +10433,7 @@
                 <a:ea typeface="Calibri" pitchFamily="34" charset="-122"/>
                 <a:cs typeface="Calibri" pitchFamily="34" charset="-120"/>
               </a:rPr>
-              <a:t>e-sud raqib emas — hamkor.</a:t>
+              <a:t>e-sud isn't a competitor — it's our partner.</a:t>
             </a:r>
             <a:endParaRPr lang="en-US" sz="1400" dirty="0"/>
           </a:p>
@@ -10582,7 +10582,7 @@
                 <a:ea typeface="Calibri" pitchFamily="34" charset="-122"/>
                 <a:cs typeface="Calibri" pitchFamily="34" charset="-120"/>
               </a:rPr>
-              <a:t>USTUNLIK</a:t>
+              <a:t>ADVANTAGE</a:t>
             </a:r>
             <a:endParaRPr lang="en-US" sz="1250" dirty="0"/>
           </a:p>
@@ -10624,7 +10624,7 @@
                 <a:ea typeface="Georgia" pitchFamily="34" charset="-122"/>
                 <a:cs typeface="Georgia" pitchFamily="34" charset="-120"/>
               </a:rPr>
-              <a:t>Nusxa ko'chirib bo'lmaydigan ustunlik.</a:t>
+              <a:t>An advantage that can't be copied.</a:t>
             </a:r>
             <a:endParaRPr lang="en-US" sz="3100" dirty="0"/>
           </a:p>
@@ -10751,7 +10751,7 @@
                 <a:ea typeface="Georgia" pitchFamily="34" charset="-122"/>
                 <a:cs typeface="Georgia" pitchFamily="34" charset="-120"/>
               </a:rPr>
-              <a:t>Oliy Sud maslahatchilari</a:t>
+              <a:t>Supreme Court advisors</a:t>
             </a:r>
             <a:endParaRPr lang="en-US" sz="1700" dirty="0"/>
           </a:p>
@@ -10793,7 +10793,7 @@
                 <a:ea typeface="Calibri" pitchFamily="34" charset="-122"/>
                 <a:cs typeface="Calibri" pitchFamily="34" charset="-120"/>
               </a:rPr>
-              <a:t>Real protsedura, real shakllar, tartibga to'liq muvofiqlik — raqib takrorlay olmaydigan munosabat.</a:t>
+              <a:t>Real procedures, real forms, full regulatory compliance — a relationship competitors can't replicate.</a:t>
             </a:r>
             <a:endParaRPr lang="en-US" sz="1250" dirty="0"/>
           </a:p>
@@ -10920,7 +10920,7 @@
                 <a:ea typeface="Georgia" pitchFamily="34" charset="-122"/>
                 <a:cs typeface="Georgia" pitchFamily="34" charset="-120"/>
               </a:rPr>
-              <a:t>O'zbek tiliga moslangan model</a:t>
+              <a:t>A model tuned for Uzbek/Russian</a:t>
             </a:r>
             <a:endParaRPr lang="en-US" sz="1700" dirty="0"/>
           </a:p>
@@ -10962,7 +10962,7 @@
                 <a:ea typeface="Calibri" pitchFamily="34" charset="-122"/>
                 <a:cs typeface="Calibri" pitchFamily="34" charset="-120"/>
               </a:rPr>
-              <a:t>Fuqaroning hikoyasini to'g'ri yuridik yo'nalishga tasniflaydi — generik modeldan ustun.</a:t>
+              <a:t>Routes a citizen's story to the right legal procedure — better than a generic model.</a:t>
             </a:r>
             <a:endParaRPr lang="en-US" sz="1250" dirty="0"/>
           </a:p>
@@ -11089,7 +11089,7 @@
                 <a:ea typeface="Georgia" pitchFamily="34" charset="-122"/>
                 <a:cs typeface="Georgia" pitchFamily="34" charset="-120"/>
               </a:rPr>
-              <a:t>Validatsiya dvigateli</a:t>
+              <a:t>A validation engine</a:t>
             </a:r>
             <a:endParaRPr lang="en-US" sz="1700" dirty="0"/>
           </a:p>
@@ -11131,7 +11131,7 @@
                 <a:ea typeface="Calibri" pitchFamily="34" charset="-122"/>
                 <a:cs typeface="Calibri" pitchFamily="34" charset="-120"/>
               </a:rPr>
-              <a:t>Rad etish sabablarini biladi; bu ma'lumotlar bazasi vaqt o'tgani sari mustahkamlanadi.</a:t>
+              <a:t>It knows why filings get rejected; this dataset compounds into a moat over time.</a:t>
             </a:r>
             <a:endParaRPr lang="en-US" sz="1250" dirty="0"/>
           </a:p>
@@ -11258,7 +11258,7 @@
                 <a:ea typeface="Georgia" pitchFamily="34" charset="-122"/>
                 <a:cs typeface="Georgia" pitchFamily="34" charset="-120"/>
               </a:rPr>
-              <a:t>Jamoa tezligi</a:t>
+              <a:t>Team speed</a:t>
             </a:r>
             <a:endParaRPr lang="en-US" sz="1700" dirty="0"/>
           </a:p>
@@ -11300,7 +11300,7 @@
                 <a:ea typeface="Calibri" pitchFamily="34" charset="-122"/>
                 <a:cs typeface="Calibri" pitchFamily="34" charset="-120"/>
               </a:rPr>
-              <a:t>Cursor Ambassador, yakka o'zi 2 ta AI mahsulot ishga tushirgan — bu hakaton mukofotlaydigan tezlik.</a:t>
+              <a:t>Cursor Ambassador; two AI products shipped solo — the speed this hackathon rewards.</a:t>
             </a:r>
             <a:endParaRPr lang="en-US" sz="1250" dirty="0"/>
           </a:p>
@@ -11449,7 +11449,7 @@
                 <a:ea typeface="Calibri" pitchFamily="34" charset="-122"/>
                 <a:cs typeface="Calibri" pitchFamily="34" charset="-120"/>
               </a:rPr>
-              <a:t>JORIY ETISH MODELI</a:t>
+              <a:t>ADOPTION MODEL</a:t>
             </a:r>
             <a:endParaRPr lang="en-US" sz="1250" dirty="0"/>
           </a:p>
@@ -11491,7 +11491,7 @@
                 <a:ea typeface="Georgia" pitchFamily="34" charset="-122"/>
                 <a:cs typeface="Georgia" pitchFamily="34" charset="-120"/>
               </a:rPr>
-              <a:t>Fuqarodan pul olmaymiz. Davlat platformani qabul qiladi.</a:t>
+              <a:t>We don't charge citizens. The government adopts it.</a:t>
             </a:r>
             <a:endParaRPr lang="en-US" sz="2800" dirty="0"/>
           </a:p>
@@ -11571,7 +11571,7 @@
               <a:buNone/>
             </a:pPr>
             <a:r>
-              <a:rPr lang="en-US" sz="2000" b="1" dirty="0">
+              <a:rPr lang="en-US" sz="1900" b="1" dirty="0">
                 <a:solidFill>
                   <a:srgbClr val="0E1B33"/>
                 </a:solidFill>
@@ -11579,9 +11579,9 @@
                 <a:ea typeface="Georgia" pitchFamily="34" charset="-122"/>
                 <a:cs typeface="Georgia" pitchFamily="34" charset="-120"/>
               </a:rPr>
-              <a:t>Davlat (B2G)</a:t>
-            </a:r>
-            <a:endParaRPr lang="en-US" sz="2000" dirty="0"/>
+              <a:t>Government (B2G)</a:t>
+            </a:r>
+            <a:endParaRPr lang="en-US" sz="1900" dirty="0"/>
           </a:p>
         </p:txBody>
       </p:sp>
@@ -11618,7 +11618,7 @@
                 <a:ea typeface="Calibri" pitchFamily="34" charset="-122"/>
                 <a:cs typeface="Calibri" pitchFamily="34" charset="-120"/>
               </a:rPr>
-              <a:t>ASOSIY</a:t>
+              <a:t>PRIMARY</a:t>
             </a:r>
             <a:endParaRPr lang="en-US" sz="1150" dirty="0"/>
           </a:p>
@@ -11660,7 +11660,7 @@
                 <a:ea typeface="Calibri" pitchFamily="34" charset="-122"/>
                 <a:cs typeface="Calibri" pitchFamily="34" charset="-120"/>
               </a:rPr>
-              <a:t>my.sud.uz uchun fuqaroga qaratilgan intellektual qatlam. G'alaba — qabulni ishga tushiradi. Davlat shartnomasi / IT Park bilan barqarorlik.</a:t>
+              <a:t>Adopted as the citizen-facing intelligence layer for my.sud.uz. Winning triggers it. Sustained by a state contract / IT Park support.</a:t>
             </a:r>
             <a:endParaRPr lang="en-US" sz="1300" dirty="0"/>
           </a:p>
@@ -11740,7 +11740,7 @@
               <a:buNone/>
             </a:pPr>
             <a:r>
-              <a:rPr lang="en-US" sz="2000" b="1" dirty="0">
+              <a:rPr lang="en-US" sz="1900" b="1" dirty="0">
                 <a:solidFill>
                   <a:srgbClr val="0E1B33"/>
                 </a:solidFill>
@@ -11748,9 +11748,9 @@
                 <a:ea typeface="Georgia" pitchFamily="34" charset="-122"/>
                 <a:cs typeface="Georgia" pitchFamily="34" charset="-120"/>
               </a:rPr>
-              <a:t>Fuqaro</a:t>
-            </a:r>
-            <a:endParaRPr lang="en-US" sz="2000" dirty="0"/>
+              <a:t>Citizens</a:t>
+            </a:r>
+            <a:endParaRPr lang="en-US" sz="1900" dirty="0"/>
           </a:p>
         </p:txBody>
       </p:sp>
@@ -11787,7 +11787,7 @@
                 <a:ea typeface="Calibri" pitchFamily="34" charset="-122"/>
                 <a:cs typeface="Calibri" pitchFamily="34" charset="-120"/>
               </a:rPr>
-              <a:t>BEPUL</a:t>
+              <a:t>FREE</a:t>
             </a:r>
             <a:endParaRPr lang="en-US" sz="1150" dirty="0"/>
           </a:p>
@@ -11829,7 +11829,7 @@
                 <a:ea typeface="Calibri" pitchFamily="34" charset="-122"/>
                 <a:cs typeface="Calibri" pitchFamily="34" charset="-120"/>
               </a:rPr>
-              <a:t>Davlat ko'magi tufayli fuqaroga bepul yoki arzon — bu ta'sir va ommaviy joriy etish hikoyasi.</a:t>
+              <a:t>Free at the point of use because it's government-backed — that's the impact, and why citizens adopt.</a:t>
             </a:r>
             <a:endParaRPr lang="en-US" sz="1300" dirty="0"/>
           </a:p>
@@ -11909,7 +11909,7 @@
               <a:buNone/>
             </a:pPr>
             <a:r>
-              <a:rPr lang="en-US" sz="2000" b="1" dirty="0">
+              <a:rPr lang="en-US" sz="1900" b="1" dirty="0">
                 <a:solidFill>
                   <a:srgbClr val="0E1B33"/>
                 </a:solidFill>
@@ -11919,7 +11919,7 @@
               </a:rPr>
               <a:t>B2B</a:t>
             </a:r>
-            <a:endParaRPr lang="en-US" sz="2000" dirty="0"/>
+            <a:endParaRPr lang="en-US" sz="1900" dirty="0"/>
           </a:p>
         </p:txBody>
       </p:sp>
@@ -11956,7 +11956,7 @@
                 <a:ea typeface="Calibri" pitchFamily="34" charset="-122"/>
                 <a:cs typeface="Calibri" pitchFamily="34" charset="-120"/>
               </a:rPr>
-              <a:t>KENGAYISH</a:t>
+              <a:t>EXPANSION</a:t>
             </a:r>
             <a:endParaRPr lang="en-US" sz="1150" dirty="0"/>
           </a:p>
@@ -11998,7 +11998,7 @@
                 <a:ea typeface="Calibri" pitchFamily="34" charset="-122"/>
                 <a:cs typeface="Calibri" pitchFamily="34" charset="-120"/>
               </a:rPr>
-              <a:t>149 “Madad” byurosi, yuridik klinikalar va KO'B uchun white-label hujjat + validatsiya.</a:t>
+              <a:t>White-label drafting + validation for the 149 “Madad” legal-aid bureaus, clinics, and SMEs.</a:t>
             </a:r>
             <a:endParaRPr lang="en-US" sz="1300" dirty="0"/>
           </a:p>
@@ -12037,7 +12037,7 @@
                 <a:ea typeface="Calibri" pitchFamily="34" charset="-122"/>
                 <a:cs typeface="Calibri" pitchFamily="34" charset="-120"/>
               </a:rPr>
-              <a:t>Unit-iqtisod:  </a:t>
+              <a:t>Unit economics:  </a:t>
             </a:r>
             <a:pPr algn="ctr" indent="0" marL="0">
               <a:buNone/>
@@ -12051,7 +12051,7 @@
                 <a:ea typeface="Calibri" pitchFamily="34" charset="-122"/>
                 <a:cs typeface="Calibri" pitchFamily="34" charset="-120"/>
               </a:rPr>
-              <a:t>advokat $125+ ga qiladigan ishni biz ~$4–8 ga — </a:t>
+              <a:t>a lawyer charges $125+; we deliver for ~$4–8 — </a:t>
             </a:r>
             <a:pPr algn="ctr" indent="0" marL="0">
               <a:buNone/>
@@ -12065,7 +12065,7 @@
                 <a:ea typeface="Calibri" pitchFamily="34" charset="-122"/>
                 <a:cs typeface="Calibri" pitchFamily="34" charset="-120"/>
               </a:rPr>
-              <a:t>10–30× arzon</a:t>
+              <a:t>10–30× cheaper</a:t>
             </a:r>
             <a:pPr algn="ctr" indent="0" marL="0">
               <a:buNone/>
@@ -12079,7 +12079,7 @@
                 <a:ea typeface="Calibri" pitchFamily="34" charset="-122"/>
                 <a:cs typeface="Calibri" pitchFamily="34" charset="-120"/>
               </a:rPr>
-              <a:t>, marginal xarajat ≈ AI inferens.</a:t>
+              <a:t>, marginal cost ≈ AI inference.</a:t>
             </a:r>
             <a:endParaRPr lang="en-US" sz="1500" dirty="0"/>
           </a:p>

</xml_diff>